<commit_message>
System Design vi: sd-14-023 and sd-14-024 decks qualify the readable JWT payload and the visible SSH bytes
Co-Authored-By: Claude Sonnet 5.5 <noreply@anthropic.com>
Claude-Session: https://claude.ai/code/session_01WnjciXNJBLEd8jy3HrG49S
</commit_message>
<xml_diff>
--- a/system-design-101/vi/lessons/sd-14-023/slides/sd-14-023.pptx
+++ b/system-design-101/vi/lessons/sd-14-023/slides/sd-14-023.pptx
@@ -3139,7 +3139,7 @@
               <a:buNone/>
             </a:pPr>
             <a:r>
-              <a:rPr lang="en-US" sz="1650" dirty="0" spc="-3" kern="0">
+              <a:rPr lang="en-US" sz="1650" dirty="0" spc="10" kern="0">
                 <a:solidFill>
                   <a:srgbClr val="9A98A0"/>
                 </a:solidFill>
@@ -3147,7 +3147,18 @@
                 <a:ea typeface="Be Vietnam Pro" pitchFamily="34" charset="-122"/>
                 <a:cs typeface="Be Vietnam Pro" pitchFamily="34" charset="-120"/>
               </a:rPr>
-              <a:t>ai</a:t>
+              <a:t>JWT</a:t>
+            </a:r>
+            <a:r>
+              <a:rPr lang="en-US" sz="1650" dirty="0" spc="1" kern="0">
+                <a:solidFill>
+                  <a:srgbClr val="9A98A0"/>
+                </a:solidFill>
+                <a:latin typeface="Be Vietnam Pro" pitchFamily="34" charset="0"/>
+                <a:ea typeface="Be Vietnam Pro" pitchFamily="34" charset="-122"/>
+                <a:cs typeface="Be Vietnam Pro" pitchFamily="34" charset="-120"/>
+              </a:rPr>
+              <a:t> ký:</a:t>
             </a:r>
             <a:r>
               <a:rPr lang="en-US" sz="1650" dirty="0" spc="0" kern="0">
@@ -3158,7 +3169,7 @@
                 <a:ea typeface="Be Vietnam Pro" pitchFamily="34" charset="-122"/>
                 <a:cs typeface="Be Vietnam Pro" pitchFamily="34" charset="-120"/>
               </a:rPr>
-              <a:t> cũng</a:t>
+              <a:t> ai cũng</a:t>
             </a:r>
             <a:r>
               <a:rPr lang="en-US" sz="1650" dirty="0" spc="8" kern="0">
@@ -10260,6 +10271,28 @@
               <a:buNone/>
             </a:pPr>
             <a:r>
+              <a:rPr lang="en-US" sz="2100" dirty="0" spc="15" kern="0">
+                <a:solidFill>
+                  <a:srgbClr val="6B6A66"/>
+                </a:solidFill>
+                <a:latin typeface="Be Vietnam Pro" pitchFamily="34" charset="0"/>
+                <a:ea typeface="Be Vietnam Pro" pitchFamily="34" charset="-122"/>
+                <a:cs typeface="Be Vietnam Pro" pitchFamily="34" charset="-120"/>
+              </a:rPr>
+              <a:t>JWT</a:t>
+            </a:r>
+            <a:r>
+              <a:rPr lang="en-US" sz="2100" dirty="0" spc="-1" kern="0">
+                <a:solidFill>
+                  <a:srgbClr val="6B6A66"/>
+                </a:solidFill>
+                <a:latin typeface="Be Vietnam Pro" pitchFamily="34" charset="0"/>
+                <a:ea typeface="Be Vietnam Pro" pitchFamily="34" charset="-122"/>
+                <a:cs typeface="Be Vietnam Pro" pitchFamily="34" charset="-120"/>
+              </a:rPr>
+              <a:t> ký:</a:t>
+            </a:r>
+            <a:r>
               <a:rPr lang="en-US" sz="2100" dirty="0" spc="-5" kern="0">
                 <a:solidFill>
                   <a:srgbClr val="6B6A66"/>
@@ -10268,8 +10301,17 @@
                 <a:ea typeface="Be Vietnam Pro" pitchFamily="34" charset="-122"/>
                 <a:cs typeface="Be Vietnam Pro" pitchFamily="34" charset="-120"/>
               </a:rPr>
-              <a:t>base64url:</a:t>
-            </a:r>
+              <a:t> base64url,</a:t>
+            </a:r>
+            <a:endParaRPr lang="en-US" sz="2100" dirty="0"/>
+          </a:p>
+          <a:p>
+            <a:pPr algn="l" indent="0" marL="0">
+              <a:lnSpc>
+                <a:spcPts val="2730"/>
+              </a:lnSpc>
+              <a:buNone/>
+            </a:pPr>
             <a:r>
               <a:rPr lang="en-US" sz="2100" dirty="0" spc="0" kern="0">
                 <a:solidFill>
@@ -10279,7 +10321,7 @@
                 <a:ea typeface="Be Vietnam Pro" pitchFamily="34" charset="-122"/>
                 <a:cs typeface="Be Vietnam Pro" pitchFamily="34" charset="-120"/>
               </a:rPr>
-              <a:t> không</a:t>
+              <a:t>không</a:t>
             </a:r>
             <a:r>
               <a:rPr lang="en-US" sz="2100" dirty="0" spc="-1" kern="0">
@@ -13907,7 +13949,7 @@
         <p:spPr>
           <a:xfrm>
             <a:off x="2857500" y="3048000"/>
-            <a:ext cx="5715000" cy="361950"/>
+            <a:ext cx="5715000" cy="800100"/>
           </a:xfrm>
           <a:prstGeom prst="rect">
             <a:avLst/>
@@ -13943,6 +13985,78 @@
                 <a:cs typeface="Be Vietnam Pro SemiBold" pitchFamily="34" charset="-120"/>
               </a:rPr>
               <a:t> 2.14.0</a:t>
+            </a:r>
+            <a:endParaRPr lang="en-US" sz="2100" dirty="0"/>
+          </a:p>
+          <a:p>
+            <a:pPr algn="l" indent="0" marL="0">
+              <a:buNone/>
+            </a:pPr>
+            <a:r>
+              <a:rPr lang="en-US" sz="1800" dirty="0" spc="9" kern="0">
+                <a:solidFill>
+                  <a:srgbClr val="14161C"/>
+                </a:solidFill>
+                <a:latin typeface="Be Vietnam Pro" pitchFamily="34" charset="0"/>
+                <a:ea typeface="Be Vietnam Pro" pitchFamily="34" charset="-122"/>
+                <a:cs typeface="Be Vietnam Pro" pitchFamily="34" charset="-120"/>
+              </a:rPr>
+              <a:t>JWT</a:t>
+            </a:r>
+            <a:r>
+              <a:rPr lang="en-US" sz="1800" dirty="0" spc="-1" kern="0">
+                <a:solidFill>
+                  <a:srgbClr val="14161C"/>
+                </a:solidFill>
+                <a:latin typeface="Be Vietnam Pro" pitchFamily="34" charset="0"/>
+                <a:ea typeface="Be Vietnam Pro" pitchFamily="34" charset="-122"/>
+                <a:cs typeface="Be Vietnam Pro" pitchFamily="34" charset="-120"/>
+              </a:rPr>
+              <a:t> mã</a:t>
+            </a:r>
+            <a:r>
+              <a:rPr lang="en-US" sz="1800" dirty="0" spc="0" kern="0">
+                <a:solidFill>
+                  <a:srgbClr val="14161C"/>
+                </a:solidFill>
+                <a:latin typeface="Be Vietnam Pro" pitchFamily="34" charset="0"/>
+                <a:ea typeface="Be Vietnam Pro" pitchFamily="34" charset="-122"/>
+                <a:cs typeface="Be Vietnam Pro" pitchFamily="34" charset="-120"/>
+              </a:rPr>
+              <a:t> hóa:</a:t>
+            </a:r>
+            <a:r>
+              <a:rPr lang="en-US" sz="1800" dirty="0" spc="-3" kern="0">
+                <a:solidFill>
+                  <a:srgbClr val="14161C"/>
+                </a:solidFill>
+                <a:latin typeface="Be Vietnam Pro" pitchFamily="34" charset="0"/>
+                <a:ea typeface="Be Vietnam Pro" pitchFamily="34" charset="-122"/>
+                <a:cs typeface="Be Vietnam Pro" pitchFamily="34" charset="-120"/>
+              </a:rPr>
+              <a:t> bài</a:t>
+            </a:r>
+            <a:r>
+              <a:rPr lang="en-US" sz="1800" dirty="0" spc="-2" kern="0">
+                <a:solidFill>
+                  <a:srgbClr val="14161C"/>
+                </a:solidFill>
+                <a:latin typeface="Be Vietnam Pro" pitchFamily="34" charset="0"/>
+                <a:ea typeface="Be Vietnam Pro" pitchFamily="34" charset="-122"/>
+                <a:cs typeface="Be Vietnam Pro" pitchFamily="34" charset="-120"/>
+              </a:rPr>
+              <a:t> không</a:t>
+            </a:r>
+            <a:r>
+              <a:rPr lang="en-US" sz="1800" dirty="0" spc="0" kern="0">
+                <a:solidFill>
+                  <a:srgbClr val="14161C"/>
+                </a:solidFill>
+                <a:latin typeface="Be Vietnam Pro" pitchFamily="34" charset="0"/>
+                <a:ea typeface="Be Vietnam Pro" pitchFamily="34" charset="-122"/>
+                <a:cs typeface="Be Vietnam Pro" pitchFamily="34" charset="-120"/>
+              </a:rPr>
+              <a:t> thử</a:t>
             </a:r>
             <a:endParaRPr lang="en-US" sz="2100" dirty="0"/>
           </a:p>
@@ -14086,7 +14200,40 @@
               <a:t> payload</a:t>
             </a:r>
             <a:r>
-              <a:rPr lang="en-US" sz="2550" dirty="0" spc="9" kern="0">
+              <a:rPr lang="en-US" sz="2550" dirty="0" spc="-2" kern="0">
+                <a:solidFill>
+                  <a:srgbClr val="14161C"/>
+                </a:solidFill>
+                <a:latin typeface="Be Vietnam Pro" pitchFamily="34" charset="0"/>
+                <a:ea typeface="Be Vietnam Pro" pitchFamily="34" charset="-122"/>
+                <a:cs typeface="Be Vietnam Pro" pitchFamily="34" charset="-120"/>
+              </a:rPr>
+              <a:t> của</a:t>
+            </a:r>
+            <a:r>
+              <a:rPr lang="en-US" sz="2550" dirty="0" spc="11" kern="0">
+                <a:solidFill>
+                  <a:srgbClr val="14161C"/>
+                </a:solidFill>
+                <a:latin typeface="Be Vietnam Pro" pitchFamily="34" charset="0"/>
+                <a:ea typeface="Be Vietnam Pro" pitchFamily="34" charset="-122"/>
+                <a:cs typeface="Be Vietnam Pro" pitchFamily="34" charset="-120"/>
+              </a:rPr>
+              <a:t> JWT</a:t>
+            </a:r>
+            <a:r>
+              <a:rPr lang="en-US" sz="2550" dirty="0" spc="0" kern="0">
+                <a:solidFill>
+                  <a:srgbClr val="14161C"/>
+                </a:solidFill>
+                <a:latin typeface="Be Vietnam Pro" pitchFamily="34" charset="0"/>
+                <a:ea typeface="Be Vietnam Pro" pitchFamily="34" charset="-122"/>
+                <a:cs typeface="Be Vietnam Pro" pitchFamily="34" charset="-120"/>
+              </a:rPr>
+              <a:t> ký</a:t>
+            </a:r>
+            <a:r>
+              <a:rPr lang="en-US" sz="2550" dirty="0" spc="10" kern="0">
                 <a:solidFill>
                   <a:srgbClr val="14161C"/>
                 </a:solidFill>
@@ -14097,7 +14244,7 @@
               <a:t> đọc</a:t>
             </a:r>
             <a:r>
-              <a:rPr lang="en-US" sz="2550" dirty="0" spc="-34" kern="0">
+              <a:rPr lang="en-US" sz="2550" dirty="0" spc="-35" kern="0">
                 <a:solidFill>
                   <a:srgbClr val="14161C"/>
                 </a:solidFill>
@@ -14116,10 +14263,21 @@
                 <a:ea typeface="Be Vietnam Pro" pitchFamily="34" charset="-122"/>
                 <a:cs typeface="Be Vietnam Pro" pitchFamily="34" charset="-120"/>
               </a:rPr>
-              <a:t> không cần</a:t>
-            </a:r>
-            <a:r>
-              <a:rPr lang="en-US" sz="2550" dirty="0" spc="-1" kern="0">
+              <a:t> không</a:t>
+            </a:r>
+            <a:r>
+              <a:rPr lang="en-US" sz="2550" dirty="0" spc="1" kern="0">
+                <a:solidFill>
+                  <a:srgbClr val="14161C"/>
+                </a:solidFill>
+                <a:latin typeface="Be Vietnam Pro" pitchFamily="34" charset="0"/>
+                <a:ea typeface="Be Vietnam Pro" pitchFamily="34" charset="-122"/>
+                <a:cs typeface="Be Vietnam Pro" pitchFamily="34" charset="-120"/>
+              </a:rPr>
+              <a:t> cần</a:t>
+            </a:r>
+            <a:r>
+              <a:rPr lang="en-US" sz="2550" dirty="0" spc="-2" kern="0">
                 <a:solidFill>
                   <a:srgbClr val="14161C"/>
                 </a:solidFill>

</xml_diff>

<commit_message>
System Design vi: sd-14-023 and sd-14-025 qualify per-node session stores, the JWT definition and the VPN tunnel encryption
Co-Authored-By: Claude Sonnet 5.5 <noreply@anthropic.com>
Claude-Session: https://claude.ai/code/session_014VvPrbj6hDb9kbRaGiTKHC
</commit_message>
<xml_diff>
--- a/system-design-101/vi/lessons/sd-14-023/slides/sd-14-023.pptx
+++ b/system-design-101/vi/lessons/sd-14-023/slides/sd-14-023.pptx
@@ -9173,7 +9173,7 @@
               <a:t> máy</a:t>
             </a:r>
             <a:r>
-              <a:rPr lang="en-US" sz="2550" dirty="0" spc="-1" kern="0">
+              <a:rPr lang="en-US" sz="2550" dirty="0" spc="0" kern="0">
                 <a:solidFill>
                   <a:srgbClr val="F3EEE3"/>
                 </a:solidFill>
@@ -9181,7 +9181,7 @@
                 <a:ea typeface="Be Vietnam Pro" pitchFamily="34" charset="-122"/>
                 <a:cs typeface="Be Vietnam Pro" pitchFamily="34" charset="-120"/>
               </a:rPr>
-              <a:t> chủ phải dùng</a:t>
+              <a:t> chủ:</a:t>
             </a:r>
             <a:r>
               <a:rPr lang="en-US" sz="2550" dirty="0" spc="1" kern="0">
@@ -9192,7 +9192,51 @@
                 <a:ea typeface="Be Vietnam Pro" pitchFamily="34" charset="-122"/>
                 <a:cs typeface="Be Vietnam Pro" pitchFamily="34" charset="-120"/>
               </a:rPr>
-              <a:t> chung kho*</a:t>
+              <a:t> chung</a:t>
+            </a:r>
+            <a:r>
+              <a:rPr lang="en-US" sz="2550" dirty="0" spc="0" kern="0">
+                <a:solidFill>
+                  <a:srgbClr val="F3EEE3"/>
+                </a:solidFill>
+                <a:latin typeface="Be Vietnam Pro" pitchFamily="34" charset="0"/>
+                <a:ea typeface="Be Vietnam Pro" pitchFamily="34" charset="-122"/>
+                <a:cs typeface="Be Vietnam Pro" pitchFamily="34" charset="-120"/>
+              </a:rPr>
+              <a:t> kho</a:t>
+            </a:r>
+            <a:r>
+              <a:rPr lang="en-US" sz="2550" dirty="0" spc="-3" kern="0">
+                <a:solidFill>
+                  <a:srgbClr val="F3EEE3"/>
+                </a:solidFill>
+                <a:latin typeface="Be Vietnam Pro" pitchFamily="34" charset="0"/>
+                <a:ea typeface="Be Vietnam Pro" pitchFamily="34" charset="-122"/>
+                <a:cs typeface="Be Vietnam Pro" pitchFamily="34" charset="-120"/>
+              </a:rPr>
+              <a:t> hoặc</a:t>
+            </a:r>
+            <a:r>
+              <a:rPr lang="en-US" sz="2550" dirty="0" spc="-12" kern="0">
+                <a:solidFill>
+                  <a:srgbClr val="F3EEE3"/>
+                </a:solidFill>
+                <a:latin typeface="Be Vietnam Pro" pitchFamily="34" charset="0"/>
+                <a:ea typeface="Be Vietnam Pro" pitchFamily="34" charset="-122"/>
+                <a:cs typeface="Be Vietnam Pro" pitchFamily="34" charset="-120"/>
+              </a:rPr>
+              <a:t> gắn</a:t>
+            </a:r>
+            <a:r>
+              <a:rPr lang="en-US" sz="2550" dirty="0" spc="-6" kern="0">
+                <a:solidFill>
+                  <a:srgbClr val="F3EEE3"/>
+                </a:solidFill>
+                <a:latin typeface="Be Vietnam Pro" pitchFamily="34" charset="0"/>
+                <a:ea typeface="Be Vietnam Pro" pitchFamily="34" charset="-122"/>
+                <a:cs typeface="Be Vietnam Pro" pitchFamily="34" charset="-120"/>
+              </a:rPr>
+              <a:t> máy*</a:t>
             </a:r>
             <a:endParaRPr lang="en-US" sz="2550" dirty="0"/>
           </a:p>

</xml_diff>

<commit_message>
System Design vi: sd-14-023 says PASETO drops the free alg field, while the version and purpose prefix still selects a fixed suite
Co-Authored-By: Claude Sonnet 5.5 <noreply@anthropic.com>
Claude-Session: https://claude.ai/code/session_014VvPrbj6hDb9kbRaGiTKHC
</commit_message>
<xml_diff>
--- a/system-design-101/vi/lessons/sd-14-023/slides/sd-14-023.pptx
+++ b/system-design-101/vi/lessons/sd-14-023/slides/sd-14-023.pptx
@@ -13249,6 +13249,28 @@
               <a:t> trường</a:t>
             </a:r>
             <a:r>
+              <a:rPr lang="en-US" sz="2700" b="1" dirty="0" spc="-1" kern="0">
+                <a:solidFill>
+                  <a:srgbClr val="3DD6A0"/>
+                </a:solidFill>
+                <a:latin typeface="Be Vietnam Pro" pitchFamily="34" charset="0"/>
+                <a:ea typeface="Be Vietnam Pro" pitchFamily="34" charset="-122"/>
+                <a:cs typeface="Be Vietnam Pro" pitchFamily="34" charset="-120"/>
+              </a:rPr>
+              <a:t> alg</a:t>
+            </a:r>
+            <a:r>
+              <a:rPr lang="en-US" sz="2700" b="1" dirty="0" spc="-3" kern="0">
+                <a:solidFill>
+                  <a:srgbClr val="3DD6A0"/>
+                </a:solidFill>
+                <a:latin typeface="Be Vietnam Pro" pitchFamily="34" charset="0"/>
+                <a:ea typeface="Be Vietnam Pro" pitchFamily="34" charset="-122"/>
+                <a:cs typeface="Be Vietnam Pro" pitchFamily="34" charset="-120"/>
+              </a:rPr>
+              <a:t> tùy</a:t>
+            </a:r>
+            <a:r>
               <a:rPr lang="en-US" sz="2700" b="1" dirty="0" spc="0" kern="0">
                 <a:solidFill>
                   <a:srgbClr val="3DD6A0"/>
@@ -13257,10 +13279,10 @@
                 <a:ea typeface="Be Vietnam Pro" pitchFamily="34" charset="-122"/>
                 <a:cs typeface="Be Vietnam Pro" pitchFamily="34" charset="-120"/>
               </a:rPr>
-              <a:t> alg:</a:t>
-            </a:r>
-            <a:r>
-              <a:rPr lang="en-US" sz="2700" b="1" dirty="0" spc="11" kern="0">
+              <a:t> ý:</a:t>
+            </a:r>
+            <a:r>
+              <a:rPr lang="en-US" sz="2700" b="1" dirty="0" spc="-4" kern="0">
                 <a:solidFill>
                   <a:srgbClr val="3DD6A0"/>
                 </a:solidFill>
@@ -13268,10 +13290,10 @@
                 <a:ea typeface="Be Vietnam Pro" pitchFamily="34" charset="-122"/>
                 <a:cs typeface="Be Vietnam Pro" pitchFamily="34" charset="-120"/>
               </a:rPr>
-              <a:t> người</a:t>
-            </a:r>
-            <a:r>
-              <a:rPr lang="en-US" sz="2700" b="1" dirty="0" spc="49" kern="0">
+              <a:t> tiền</a:t>
+            </a:r>
+            <a:r>
+              <a:rPr lang="en-US" sz="2700" b="1" dirty="0" spc="-9" kern="0">
                 <a:solidFill>
                   <a:srgbClr val="3DD6A0"/>
                 </a:solidFill>
@@ -13279,7 +13301,7 @@
                 <a:ea typeface="Be Vietnam Pro" pitchFamily="34" charset="-122"/>
                 <a:cs typeface="Be Vietnam Pro" pitchFamily="34" charset="-120"/>
               </a:rPr>
-              <a:t> gửi</a:t>
+              <a:t> tố</a:t>
             </a:r>
             <a:r>
               <a:rPr lang="en-US" sz="2700" b="1" dirty="0" spc="-6" kern="0">
@@ -13290,10 +13312,10 @@
                 <a:ea typeface="Be Vietnam Pro" pitchFamily="34" charset="-122"/>
                 <a:cs typeface="Be Vietnam Pro" pitchFamily="34" charset="-120"/>
               </a:rPr>
-              <a:t> không</a:t>
-            </a:r>
-            <a:r>
-              <a:rPr lang="en-US" sz="2700" b="1" dirty="0" spc="-8" kern="0">
+              <a:t> chọn</a:t>
+            </a:r>
+            <a:r>
+              <a:rPr lang="en-US" sz="2700" b="1" dirty="0" spc="-4" kern="0">
                 <a:solidFill>
                   <a:srgbClr val="3DD6A0"/>
                 </a:solidFill>
@@ -13301,10 +13323,10 @@
                 <a:ea typeface="Be Vietnam Pro" pitchFamily="34" charset="-122"/>
                 <a:cs typeface="Be Vietnam Pro" pitchFamily="34" charset="-120"/>
               </a:rPr>
-              <a:t> còn</a:t>
-            </a:r>
-            <a:r>
-              <a:rPr lang="en-US" sz="2700" b="1" dirty="0" spc="-4" kern="0">
+              <a:t> bộ</a:t>
+            </a:r>
+            <a:r>
+              <a:rPr lang="en-US" sz="2700" b="1" dirty="0" spc="-5" kern="0">
                 <a:solidFill>
                   <a:srgbClr val="3DD6A0"/>
                 </a:solidFill>
@@ -13312,7 +13334,7 @@
                 <a:ea typeface="Be Vietnam Pro" pitchFamily="34" charset="-122"/>
                 <a:cs typeface="Be Vietnam Pro" pitchFamily="34" charset="-120"/>
               </a:rPr>
-              <a:t> tự</a:t>
+              <a:t> thuật</a:t>
             </a:r>
             <a:r>
               <a:rPr lang="en-US" sz="2700" b="1" dirty="0" spc="-6" kern="0">
@@ -13323,10 +13345,10 @@
                 <a:ea typeface="Be Vietnam Pro" pitchFamily="34" charset="-122"/>
                 <a:cs typeface="Be Vietnam Pro" pitchFamily="34" charset="-120"/>
               </a:rPr>
-              <a:t> chọn</a:t>
-            </a:r>
-            <a:r>
-              <a:rPr lang="en-US" sz="2700" b="1" dirty="0" spc="-5" kern="0">
+              <a:t> toán</a:t>
+            </a:r>
+            <a:r>
+              <a:rPr lang="en-US" sz="2700" b="1" dirty="0" spc="-7" kern="0">
                 <a:solidFill>
                   <a:srgbClr val="3DD6A0"/>
                 </a:solidFill>
@@ -13334,10 +13356,10 @@
                 <a:ea typeface="Be Vietnam Pro" pitchFamily="34" charset="-122"/>
                 <a:cs typeface="Be Vietnam Pro" pitchFamily="34" charset="-120"/>
               </a:rPr>
-              <a:t> thuật</a:t>
-            </a:r>
-            <a:r>
-              <a:rPr lang="en-US" sz="2700" b="1" dirty="0" spc="-4" kern="0">
+              <a:t> cố</a:t>
+            </a:r>
+            <a:r>
+              <a:rPr lang="en-US" sz="2700" b="1" dirty="0" spc="14" kern="0">
                 <a:solidFill>
                   <a:srgbClr val="3DD6A0"/>
                 </a:solidFill>
@@ -13345,7 +13367,7 @@
                 <a:ea typeface="Be Vietnam Pro" pitchFamily="34" charset="-122"/>
                 <a:cs typeface="Be Vietnam Pro" pitchFamily="34" charset="-120"/>
               </a:rPr>
-              <a:t> toán.</a:t>
+              <a:t> định.</a:t>
             </a:r>
             <a:endParaRPr lang="en-US" sz="2700" dirty="0"/>
           </a:p>

</xml_diff>

<commit_message>
System Design vi: sd-14-023 scopes the cookie claim to server-side sessions
Co-Authored-By: Claude Sonnet 5.5 <noreply@anthropic.com>
Claude-Session: https://claude.ai/code/session_014VvPrbj6hDb9kbRaGiTKHC
</commit_message>
<xml_diff>
--- a/system-design-101/vi/lessons/sd-14-023/slides/sd-14-023.pptx
+++ b/system-design-101/vi/lessons/sd-14-023/slides/sd-14-023.pptx
@@ -6260,15 +6260,26 @@
               <a:buNone/>
             </a:pPr>
             <a:r>
-              <a:rPr lang="en-US" sz="2250" dirty="0" spc="-4" kern="0">
-                <a:solidFill>
-                  <a:srgbClr val="14161C"/>
-                </a:solidFill>
-                <a:latin typeface="Be Vietnam Pro" pitchFamily="34" charset="0"/>
-                <a:ea typeface="Be Vietnam Pro" pitchFamily="34" charset="-122"/>
-                <a:cs typeface="Be Vietnam Pro" pitchFamily="34" charset="-120"/>
-              </a:rPr>
-              <a:t>Chỉ</a:t>
+              <a:rPr lang="en-US" sz="2250" dirty="0" spc="-3" kern="0">
+                <a:solidFill>
+                  <a:srgbClr val="14161C"/>
+                </a:solidFill>
+                <a:latin typeface="Be Vietnam Pro" pitchFamily="34" charset="0"/>
+                <a:ea typeface="Be Vietnam Pro" pitchFamily="34" charset="-122"/>
+                <a:cs typeface="Be Vietnam Pro" pitchFamily="34" charset="-120"/>
+              </a:rPr>
+              <a:t>Mang</a:t>
+            </a:r>
+            <a:r>
+              <a:rPr lang="en-US" sz="2250" dirty="0" spc="-2" kern="0">
+                <a:solidFill>
+                  <a:srgbClr val="14161C"/>
+                </a:solidFill>
+                <a:latin typeface="Be Vietnam Pro" pitchFamily="34" charset="0"/>
+                <a:ea typeface="Be Vietnam Pro" pitchFamily="34" charset="-122"/>
+                <a:cs typeface="Be Vietnam Pro" pitchFamily="34" charset="-120"/>
+              </a:rPr>
+              <a:t> mã</a:t>
             </a:r>
             <a:r>
               <a:rPr lang="en-US" sz="2250" dirty="0" spc="-1" kern="0">
@@ -6279,29 +6290,7 @@
                 <a:ea typeface="Be Vietnam Pro" pitchFamily="34" charset="-122"/>
                 <a:cs typeface="Be Vietnam Pro" pitchFamily="34" charset="-120"/>
               </a:rPr>
-              <a:t> mang</a:t>
-            </a:r>
-            <a:r>
-              <a:rPr lang="en-US" sz="2250" dirty="0" spc="-4" kern="0">
-                <a:solidFill>
-                  <a:srgbClr val="14161C"/>
-                </a:solidFill>
-                <a:latin typeface="Be Vietnam Pro" pitchFamily="34" charset="0"/>
-                <a:ea typeface="Be Vietnam Pro" pitchFamily="34" charset="-122"/>
-                <a:cs typeface="Be Vietnam Pro" pitchFamily="34" charset="-120"/>
-              </a:rPr>
-              <a:t> một</a:t>
-            </a:r>
-            <a:r>
-              <a:rPr lang="en-US" sz="2250" dirty="0" spc="1" kern="0">
-                <a:solidFill>
-                  <a:srgbClr val="14161C"/>
-                </a:solidFill>
-                <a:latin typeface="Be Vietnam Pro" pitchFamily="34" charset="0"/>
-                <a:ea typeface="Be Vietnam Pro" pitchFamily="34" charset="-122"/>
-                <a:cs typeface="Be Vietnam Pro" pitchFamily="34" charset="-120"/>
-              </a:rPr>
-              <a:t> mã.</a:t>
+              <a:t> session.</a:t>
             </a:r>
             <a:endParaRPr lang="en-US" sz="2250" dirty="0"/>
           </a:p>
@@ -8643,6 +8632,39 @@
               <a:buNone/>
             </a:pPr>
             <a:r>
+              <a:rPr lang="en-US" sz="1950" dirty="0" spc="-29" kern="0">
+                <a:solidFill>
+                  <a:srgbClr val="9A98A0"/>
+                </a:solidFill>
+                <a:latin typeface="Be Vietnam Pro" pitchFamily="34" charset="0"/>
+                <a:ea typeface="Be Vietnam Pro" pitchFamily="34" charset="-122"/>
+                <a:cs typeface="Be Vietnam Pro" pitchFamily="34" charset="-120"/>
+              </a:rPr>
+              <a:t>Với</a:t>
+            </a:r>
+            <a:r>
+              <a:rPr lang="en-US" sz="1950" dirty="0" spc="0" kern="0">
+                <a:solidFill>
+                  <a:srgbClr val="9A98A0"/>
+                </a:solidFill>
+                <a:latin typeface="Be Vietnam Pro" pitchFamily="34" charset="0"/>
+                <a:ea typeface="Be Vietnam Pro" pitchFamily="34" charset="-122"/>
+                <a:cs typeface="Be Vietnam Pro" pitchFamily="34" charset="-120"/>
+              </a:rPr>
+              <a:t> session phía</a:t>
+            </a:r>
+            <a:r>
+              <a:rPr lang="en-US" sz="1950" dirty="0" spc="-7" kern="0">
+                <a:solidFill>
+                  <a:srgbClr val="9A98A0"/>
+                </a:solidFill>
+                <a:latin typeface="Be Vietnam Pro" pitchFamily="34" charset="0"/>
+                <a:ea typeface="Be Vietnam Pro" pitchFamily="34" charset="-122"/>
+                <a:cs typeface="Be Vietnam Pro" pitchFamily="34" charset="-120"/>
+              </a:rPr>
+              <a:t> máy</a:t>
+            </a:r>
+            <a:r>
               <a:rPr lang="en-US" sz="1950" dirty="0" spc="-1" kern="0">
                 <a:solidFill>
                   <a:srgbClr val="9A98A0"/>
@@ -8651,10 +8673,10 @@
                 <a:ea typeface="Be Vietnam Pro" pitchFamily="34" charset="-122"/>
                 <a:cs typeface="Be Vietnam Pro" pitchFamily="34" charset="-120"/>
               </a:rPr>
-              <a:t>Cookie chỉ</a:t>
-            </a:r>
-            <a:r>
-              <a:rPr lang="en-US" sz="1950" dirty="0" spc="2" kern="0">
+              <a:t> chủ, cookie</a:t>
+            </a:r>
+            <a:r>
+              <a:rPr lang="en-US" sz="1950" dirty="0" spc="-2" kern="0">
                 <a:solidFill>
                   <a:srgbClr val="9A98A0"/>
                 </a:solidFill>
@@ -8662,10 +8684,21 @@
                 <a:ea typeface="Be Vietnam Pro" pitchFamily="34" charset="-122"/>
                 <a:cs typeface="Be Vietnam Pro" pitchFamily="34" charset="-120"/>
               </a:rPr>
+              <a:t> chỉ</a:t>
+            </a:r>
+            <a:r>
+              <a:rPr lang="en-US" sz="1950" dirty="0" spc="3" kern="0">
+                <a:solidFill>
+                  <a:srgbClr val="9A98A0"/>
+                </a:solidFill>
+                <a:latin typeface="Be Vietnam Pro" pitchFamily="34" charset="0"/>
+                <a:ea typeface="Be Vietnam Pro" pitchFamily="34" charset="-122"/>
+                <a:cs typeface="Be Vietnam Pro" pitchFamily="34" charset="-120"/>
+              </a:rPr>
               <a:t> mang</a:t>
             </a:r>
             <a:r>
-              <a:rPr lang="en-US" sz="1950" dirty="0" spc="-5" kern="0">
+              <a:rPr lang="en-US" sz="1950" dirty="0" spc="-6" kern="0">
                 <a:solidFill>
                   <a:srgbClr val="9A98A0"/>
                 </a:solidFill>
@@ -8687,7 +8720,7 @@
               <a:t> mã;</a:t>
             </a:r>
             <a:r>
-              <a:rPr lang="en-US" sz="1950" dirty="0" spc="-2" kern="0">
+              <a:rPr lang="en-US" sz="1950" dirty="0" spc="-1" kern="0">
                 <a:solidFill>
                   <a:srgbClr val="9A98A0"/>
                 </a:solidFill>
@@ -8698,7 +8731,7 @@
               <a:t> ý</a:t>
             </a:r>
             <a:r>
-              <a:rPr lang="en-US" sz="1950" dirty="0" spc="2" kern="0">
+              <a:rPr lang="en-US" sz="1950" dirty="0" spc="1" kern="0">
                 <a:solidFill>
                   <a:srgbClr val="9A98A0"/>
                 </a:solidFill>
@@ -8709,6 +8742,39 @@
               <a:t> nghĩa</a:t>
             </a:r>
             <a:r>
+              <a:rPr lang="en-US" sz="1950" dirty="0" spc="0" kern="0">
+                <a:solidFill>
+                  <a:srgbClr val="9A98A0"/>
+                </a:solidFill>
+                <a:latin typeface="Be Vietnam Pro" pitchFamily="34" charset="0"/>
+                <a:ea typeface="Be Vietnam Pro" pitchFamily="34" charset="-122"/>
+                <a:cs typeface="Be Vietnam Pro" pitchFamily="34" charset="-120"/>
+              </a:rPr>
+              <a:t> của</a:t>
+            </a:r>
+            <a:r>
+              <a:rPr lang="en-US" sz="1950" dirty="0" spc="1" kern="0">
+                <a:solidFill>
+                  <a:srgbClr val="9A98A0"/>
+                </a:solidFill>
+                <a:latin typeface="Be Vietnam Pro" pitchFamily="34" charset="0"/>
+                <a:ea typeface="Be Vietnam Pro" pitchFamily="34" charset="-122"/>
+                <a:cs typeface="Be Vietnam Pro" pitchFamily="34" charset="-120"/>
+              </a:rPr>
+              <a:t> mã nằm</a:t>
+            </a:r>
+            <a:r>
+              <a:rPr lang="en-US" sz="1950" dirty="0" spc="-12" kern="0">
+                <a:solidFill>
+                  <a:srgbClr val="9A98A0"/>
+                </a:solidFill>
+                <a:latin typeface="Be Vietnam Pro" pitchFamily="34" charset="0"/>
+                <a:ea typeface="Be Vietnam Pro" pitchFamily="34" charset="-122"/>
+                <a:cs typeface="Be Vietnam Pro" pitchFamily="34" charset="-120"/>
+              </a:rPr>
+              <a:t> trong</a:t>
+            </a:r>
+            <a:r>
               <a:rPr lang="en-US" sz="1950" dirty="0" spc="-1" kern="0">
                 <a:solidFill>
                   <a:srgbClr val="9A98A0"/>
@@ -8717,7 +8783,7 @@
                 <a:ea typeface="Be Vietnam Pro" pitchFamily="34" charset="-122"/>
                 <a:cs typeface="Be Vietnam Pro" pitchFamily="34" charset="-120"/>
               </a:rPr>
-              <a:t> của</a:t>
+              <a:t> kho</a:t>
             </a:r>
             <a:r>
               <a:rPr lang="en-US" sz="1950" dirty="0" spc="0" kern="0">
@@ -8728,84 +8794,7 @@
                 <a:ea typeface="Be Vietnam Pro" pitchFamily="34" charset="-122"/>
                 <a:cs typeface="Be Vietnam Pro" pitchFamily="34" charset="-120"/>
               </a:rPr>
-              <a:t> mã</a:t>
-            </a:r>
-            <a:r>
-              <a:rPr lang="en-US" sz="1950" dirty="0" spc="2" kern="0">
-                <a:solidFill>
-                  <a:srgbClr val="9A98A0"/>
-                </a:solidFill>
-                <a:latin typeface="Be Vietnam Pro" pitchFamily="34" charset="0"/>
-                <a:ea typeface="Be Vietnam Pro" pitchFamily="34" charset="-122"/>
-                <a:cs typeface="Be Vietnam Pro" pitchFamily="34" charset="-120"/>
-              </a:rPr>
-              <a:t> nằm</a:t>
-            </a:r>
-            <a:r>
-              <a:rPr lang="en-US" sz="1950" dirty="0" spc="-12" kern="0">
-                <a:solidFill>
-                  <a:srgbClr val="9A98A0"/>
-                </a:solidFill>
-                <a:latin typeface="Be Vietnam Pro" pitchFamily="34" charset="0"/>
-                <a:ea typeface="Be Vietnam Pro" pitchFamily="34" charset="-122"/>
-                <a:cs typeface="Be Vietnam Pro" pitchFamily="34" charset="-120"/>
-              </a:rPr>
-              <a:t> trong</a:t>
-            </a:r>
-            <a:r>
-              <a:rPr lang="en-US" sz="1950" dirty="0" spc="-1" kern="0">
-                <a:solidFill>
-                  <a:srgbClr val="9A98A0"/>
-                </a:solidFill>
-                <a:latin typeface="Be Vietnam Pro" pitchFamily="34" charset="0"/>
-                <a:ea typeface="Be Vietnam Pro" pitchFamily="34" charset="-122"/>
-                <a:cs typeface="Be Vietnam Pro" pitchFamily="34" charset="-120"/>
-              </a:rPr>
-              <a:t> kho</a:t>
-            </a:r>
-            <a:r>
-              <a:rPr lang="en-US" sz="1950" dirty="0" spc="0" kern="0">
-                <a:solidFill>
-                  <a:srgbClr val="9A98A0"/>
-                </a:solidFill>
-                <a:latin typeface="Be Vietnam Pro" pitchFamily="34" charset="0"/>
-                <a:ea typeface="Be Vietnam Pro" pitchFamily="34" charset="-122"/>
-                <a:cs typeface="Be Vietnam Pro" pitchFamily="34" charset="-120"/>
-              </a:rPr>
-              <a:t> session</a:t>
-            </a:r>
-            <a:r>
-              <a:rPr lang="en-US" sz="1950" dirty="0" spc="-2" kern="0">
-                <a:solidFill>
-                  <a:srgbClr val="9A98A0"/>
-                </a:solidFill>
-                <a:latin typeface="Be Vietnam Pro" pitchFamily="34" charset="0"/>
-                <a:ea typeface="Be Vietnam Pro" pitchFamily="34" charset="-122"/>
-                <a:cs typeface="Be Vietnam Pro" pitchFamily="34" charset="-120"/>
-              </a:rPr>
-              <a:t> ở</a:t>
-            </a:r>
-            <a:r>
-              <a:rPr lang="en-US" sz="1950" dirty="0" spc="-7" kern="0">
-                <a:solidFill>
-                  <a:srgbClr val="9A98A0"/>
-                </a:solidFill>
-                <a:latin typeface="Be Vietnam Pro" pitchFamily="34" charset="0"/>
-                <a:ea typeface="Be Vietnam Pro" pitchFamily="34" charset="-122"/>
-                <a:cs typeface="Be Vietnam Pro" pitchFamily="34" charset="-120"/>
-              </a:rPr>
-              <a:t> máy</a:t>
-            </a:r>
-            <a:r>
-              <a:rPr lang="en-US" sz="1950" dirty="0" spc="-2" kern="0">
-                <a:solidFill>
-                  <a:srgbClr val="9A98A0"/>
-                </a:solidFill>
-                <a:latin typeface="Be Vietnam Pro" pitchFamily="34" charset="0"/>
-                <a:ea typeface="Be Vietnam Pro" pitchFamily="34" charset="-122"/>
-                <a:cs typeface="Be Vietnam Pro" pitchFamily="34" charset="-120"/>
-              </a:rPr>
-              <a:t> chủ.</a:t>
+              <a:t> session.</a:t>
             </a:r>
             <a:endParaRPr lang="en-US" sz="1950" dirty="0"/>
           </a:p>

</xml_diff>

<commit_message>
System Design vi: sd-14-023 separates the v4.public signature from the exp check
Co-Authored-By: Claude Sonnet 5.5 <noreply@anthropic.com>
Claude-Session: https://claude.ai/code/session_014VvPrbj6hDb9kbRaGiTKHC
</commit_message>
<xml_diff>
--- a/system-design-101/vi/lessons/sd-14-023/slides/sd-14-023.pptx
+++ b/system-design-101/vi/lessons/sd-14-023/slides/sd-14-023.pptx
@@ -22594,7 +22594,40 @@
                 <a:ea typeface="Be Vietnam Pro" pitchFamily="34" charset="-122"/>
                 <a:cs typeface="Be Vietnam Pro" pitchFamily="34" charset="-120"/>
               </a:rPr>
-              <a:t> hợp</a:t>
+              <a:t> hợp lệ;</a:t>
+            </a:r>
+            <a:r>
+              <a:rPr lang="en-US" sz="2550" dirty="0" spc="-19" kern="0">
+                <a:solidFill>
+                  <a:srgbClr val="FFFFFF"/>
+                </a:solidFill>
+                <a:latin typeface="Be Vietnam Pro" pitchFamily="34" charset="0"/>
+                <a:ea typeface="Be Vietnam Pro" pitchFamily="34" charset="-122"/>
+                <a:cs typeface="Be Vietnam Pro" pitchFamily="34" charset="-120"/>
+              </a:rPr>
+              <a:t> exp</a:t>
+            </a:r>
+            <a:r>
+              <a:rPr lang="en-US" sz="2550" dirty="0" spc="0" kern="0">
+                <a:solidFill>
+                  <a:srgbClr val="FFFFFF"/>
+                </a:solidFill>
+                <a:latin typeface="Be Vietnam Pro" pitchFamily="34" charset="0"/>
+                <a:ea typeface="Be Vietnam Pro" pitchFamily="34" charset="-122"/>
+                <a:cs typeface="Be Vietnam Pro" pitchFamily="34" charset="-120"/>
+              </a:rPr>
+              <a:t> do</a:t>
+            </a:r>
+            <a:r>
+              <a:rPr lang="en-US" sz="2550" dirty="0" spc="-1" kern="0">
+                <a:solidFill>
+                  <a:srgbClr val="FFFFFF"/>
+                </a:solidFill>
+                <a:latin typeface="Be Vietnam Pro" pitchFamily="34" charset="0"/>
+                <a:ea typeface="Be Vietnam Pro" pitchFamily="34" charset="-122"/>
+                <a:cs typeface="Be Vietnam Pro" pitchFamily="34" charset="-120"/>
+              </a:rPr>
+              <a:t> thư viện</a:t>
             </a:r>
             <a:r>
               <a:rPr lang="en-US" sz="2550" dirty="0" spc="1" kern="0">
@@ -22605,51 +22638,7 @@
                 <a:ea typeface="Be Vietnam Pro" pitchFamily="34" charset="-122"/>
                 <a:cs typeface="Be Vietnam Pro" pitchFamily="34" charset="-120"/>
               </a:rPr>
-              <a:t> lệ</a:t>
-            </a:r>
-            <a:r>
-              <a:rPr lang="en-US" sz="2550" dirty="0" spc="-13" kern="0">
-                <a:solidFill>
-                  <a:srgbClr val="FFFFFF"/>
-                </a:solidFill>
-                <a:latin typeface="Be Vietnam Pro" pitchFamily="34" charset="0"/>
-                <a:ea typeface="Be Vietnam Pro" pitchFamily="34" charset="-122"/>
-                <a:cs typeface="Be Vietnam Pro" pitchFamily="34" charset="-120"/>
-              </a:rPr>
-              <a:t> tới</a:t>
-            </a:r>
-            <a:r>
-              <a:rPr lang="en-US" sz="2550" dirty="0" spc="-1" kern="0">
-                <a:solidFill>
-                  <a:srgbClr val="FFFFFF"/>
-                </a:solidFill>
-                <a:latin typeface="Be Vietnam Pro" pitchFamily="34" charset="0"/>
-                <a:ea typeface="Be Vietnam Pro" pitchFamily="34" charset="-122"/>
-                <a:cs typeface="Be Vietnam Pro" pitchFamily="34" charset="-120"/>
-              </a:rPr>
-              <a:t> lúc</a:t>
-            </a:r>
-            <a:r>
-              <a:rPr lang="en-US" sz="2550" dirty="0" spc="-5" kern="0">
-                <a:solidFill>
-                  <a:srgbClr val="FFFFFF"/>
-                </a:solidFill>
-                <a:latin typeface="Be Vietnam Pro" pitchFamily="34" charset="0"/>
-                <a:ea typeface="Be Vietnam Pro" pitchFamily="34" charset="-122"/>
-                <a:cs typeface="Be Vietnam Pro" pitchFamily="34" charset="-120"/>
-              </a:rPr>
-              <a:t> hết</a:t>
-            </a:r>
-            <a:r>
-              <a:rPr lang="en-US" sz="2550" dirty="0" spc="1" kern="0">
-                <a:solidFill>
-                  <a:srgbClr val="FFFFFF"/>
-                </a:solidFill>
-                <a:latin typeface="Be Vietnam Pro" pitchFamily="34" charset="0"/>
-                <a:ea typeface="Be Vietnam Pro" pitchFamily="34" charset="-122"/>
-                <a:cs typeface="Be Vietnam Pro" pitchFamily="34" charset="-120"/>
-              </a:rPr>
-              <a:t> hạn.</a:t>
+              <a:t> kiểm.</a:t>
             </a:r>
             <a:endParaRPr lang="en-US" sz="2550" dirty="0"/>
           </a:p>

</xml_diff>